<commit_message>
Remap course animations withdrawn on main
Main withdrew 14 held 'watch-' study clips (a51ca51). Two have direct Flow
replacements (compost heap, mulching); the other 12 references become NEW
items with their own briefs, generated per course in that course's look.
build.py --check: 0 problems; 49 NEW animations queued for Flow/Veo.

Co-Authored-By: Claude Opus 5.5 <noreply@anthropic.com>
Claude-Session: https://claude.ai/code/session_01DVvirN1GL3YvgFnXUT6gyq
</commit_message>
<xml_diff>
--- a/courses/build/ai-literacy/A-D2.pptx
+++ b/courses/build/ai-literacy/A-D2.pptx
@@ -1380,7 +1380,7 @@
           </a:p>
           <a:p>
             <a:r>
-              <a:t>Clip A-ANI-07: public/course-animations/market-community/watch-04-farm-record.mp4</a:t>
+              <a:t>Clip A-ANI-07: public/course-media/ai-literacy/A-ANI-07.mp4</a:t>
             </a:r>
           </a:p>
         </p:txBody>
@@ -1557,7 +1557,7 @@
           </a:p>
           <a:p>
             <a:r>
-              <a:t>Clip A-ANI-06: public/course-animations/soil-health/tour-soil-observation.mp4</a:t>
+              <a:t>Clip A-ANI-06: public/course-media/ai-literacy/A-ANI-06.mp4</a:t>
             </a:r>
           </a:p>
         </p:txBody>
@@ -1906,7 +1906,7 @@
           </a:p>
           <a:p>
             <a:r>
-              <a:t>Clip A-ANI-05: public/course-animations/reading-landscape/watch-09-sun-shadows.mp4</a:t>
+              <a:t>Clip A-ANI-05: public/course-media/ai-literacy/A-ANI-05.mp4</a:t>
             </a:r>
           </a:p>
         </p:txBody>

</xml_diff>